<commit_message>
test(e2e): replace the fixtures with a more thoroughly verified set
Same filenames, better documents, and a verifier that proves more of what
the specs depend on. The set now also carries a genuinely encrypted Office
file (CFB container, ECMA-376 agile encryption) and an opaque unknown-format
blob, which the first pass could not produce.

Regeneration is byte-identical except for the two encrypted files, which
embed fresh salts by design. `--verify` re-checks every claim: the heavy
contract stays above the CDN cutoff, the workbook past the row cap, the scan
has zero extractable text (checked both through the content streams and with
pdftotext), the damaged file still fails to parse, and the encrypted ones
still refuse an empty password.

The preview matrix has to be re-run against these before any of its rows can
be marked covered — see the investigation note in COVERAGE_MAP.md.

Co-Authored-By: Claude Fable 5 <noreply@anthropic.com>
</commit_message>
<xml_diff>
--- a/e2e/fixtures/files/deck-16x9.pptx
+++ b/e2e/fixtures/files/deck-16x9.pptx
@@ -3115,7 +3115,7 @@
           <a:lstStyle/>
           <a:p>
             <a:r>
-              <a:t>Итоги полугодия</a:t>
+              <a:t>Отчёт по договорной работе</a:t>
             </a:r>
           </a:p>
         </p:txBody>
@@ -3136,7 +3136,7 @@
           <a:lstStyle/>
           <a:p>
             <a:r>
-              <a:t>ООО «Ромашка» · январь 2026</a:t>
+              <a:t>ООО «Ромашка» · IV квартал 2024 · для внутреннего использования</a:t>
             </a:r>
           </a:p>
         </p:txBody>
@@ -3175,7 +3175,7 @@
           <a:lstStyle/>
           <a:p>
             <a:r>
-              <a:t>Раздел 9</a:t>
+              <a:t>Команда</a:t>
             </a:r>
           </a:p>
         </p:txBody>
@@ -3196,23 +3196,19 @@
           <a:lstStyle/>
           <a:p>
             <a:r>
-              <a:t>Ключевой показатель 9</a:t>
-            </a:r>
-          </a:p>
-          <a:p>
-            <a:pPr lvl="1">
-              <a:defRPr sz="1800"/>
-            </a:pPr>
-            <a:r>
-              <a:t>Пояснение 9.1</a:t>
-            </a:r>
-          </a:p>
-          <a:p>
-            <a:pPr lvl="1">
-              <a:defRPr sz="1800"/>
-            </a:pPr>
-            <a:r>
-              <a:t>Пояснение 9.2</a:t>
+              <a:t>Руководитель проекта — П. П. Петров</a:t>
+            </a:r>
+          </a:p>
+          <a:p>
+            <a:pPr lvl="1"/>
+            <a:r>
+              <a:t>Аналитик — А. В. Кузнецова</a:t>
+            </a:r>
+          </a:p>
+          <a:p>
+            <a:pPr lvl="1"/>
+            <a:r>
+              <a:t>Юрист — С. С. Сидоров</a:t>
             </a:r>
           </a:p>
         </p:txBody>
@@ -3251,48 +3247,309 @@
           <a:lstStyle/>
           <a:p>
             <a:r>
-              <a:t>Раздел 10</a:t>
-            </a:r>
-          </a:p>
-        </p:txBody>
-      </p:sp>
-      <p:sp>
-        <p:nvSpPr>
-          <p:cNvPr id="3" name="Content Placeholder 2"/>
-          <p:cNvSpPr>
-            <a:spLocks noGrp="1"/>
-          </p:cNvSpPr>
-          <p:nvPr>
-            <p:ph idx="1"/>
-          </p:nvPr>
-        </p:nvSpPr>
-        <p:spPr/>
-        <p:txBody>
-          <a:bodyPr/>
-          <a:lstStyle/>
-          <a:p>
-            <a:r>
-              <a:t>Ключевой показатель 10</a:t>
-            </a:r>
-          </a:p>
-          <a:p>
-            <a:pPr lvl="1">
-              <a:defRPr sz="1800"/>
-            </a:pPr>
-            <a:r>
-              <a:t>Пояснение 10.1</a:t>
-            </a:r>
-          </a:p>
-          <a:p>
-            <a:pPr lvl="1">
-              <a:defRPr sz="1800"/>
-            </a:pPr>
-            <a:r>
-              <a:t>Пояснение 10.2</a:t>
-            </a:r>
-          </a:p>
-        </p:txBody>
-      </p:sp>
+              <a:t>Реестр крупных договоров</a:t>
+            </a:r>
+          </a:p>
+        </p:txBody>
+      </p:sp>
+      <p:graphicFrame>
+        <p:nvGraphicFramePr>
+          <p:cNvPr id="3" name="Table 2"/>
+          <p:cNvGraphicFramePr>
+            <a:graphicFrameLocks noGrp="1"/>
+          </p:cNvGraphicFramePr>
+          <p:nvPr/>
+        </p:nvGraphicFramePr>
+        <p:xfrm>
+          <a:off x="720000" y="1440000"/>
+          <a:ext cx="10752000" cy="2880000"/>
+        </p:xfrm>
+        <a:graphic>
+          <a:graphicData uri="http://schemas.openxmlformats.org/drawingml/2006/table">
+            <a:tbl>
+              <a:tblPr firstRow="1" bandRow="1">
+                <a:tableStyleId>{5C22544A-7EE6-4342-B048-85BDC9FD1C3A}</a:tableStyleId>
+              </a:tblPr>
+              <a:tblGrid>
+                <a:gridCol w="2688000"/>
+                <a:gridCol w="2688000"/>
+                <a:gridCol w="2688000"/>
+                <a:gridCol w="2688000"/>
+              </a:tblGrid>
+              <a:tr h="576000">
+                <a:tc>
+                  <a:txBody>
+                    <a:bodyPr/>
+                    <a:lstStyle/>
+                    <a:p>
+                      <a:r>
+                        <a:rPr sz="1400"/>
+                        <a:t>Договор</a:t>
+                      </a:r>
+                    </a:p>
+                  </a:txBody>
+                  <a:tcPr/>
+                </a:tc>
+                <a:tc>
+                  <a:txBody>
+                    <a:bodyPr/>
+                    <a:lstStyle/>
+                    <a:p>
+                      <a:r>
+                        <a:rPr sz="1400"/>
+                        <a:t>Контрагент</a:t>
+                      </a:r>
+                    </a:p>
+                  </a:txBody>
+                  <a:tcPr/>
+                </a:tc>
+                <a:tc>
+                  <a:txBody>
+                    <a:bodyPr/>
+                    <a:lstStyle/>
+                    <a:p>
+                      <a:r>
+                        <a:rPr sz="1400"/>
+                        <a:t>Сумма, BYN</a:t>
+                      </a:r>
+                    </a:p>
+                  </a:txBody>
+                  <a:tcPr/>
+                </a:tc>
+                <a:tc>
+                  <a:txBody>
+                    <a:bodyPr/>
+                    <a:lstStyle/>
+                    <a:p>
+                      <a:r>
+                        <a:rPr sz="1400"/>
+                        <a:t>Статус</a:t>
+                      </a:r>
+                    </a:p>
+                  </a:txBody>
+                  <a:tcPr/>
+                </a:tc>
+              </a:tr>
+              <a:tr h="576000">
+                <a:tc>
+                  <a:txBody>
+                    <a:bodyPr/>
+                    <a:lstStyle/>
+                    <a:p>
+                      <a:r>
+                        <a:rPr sz="1400"/>
+                        <a:t>№ 17/2024</a:t>
+                      </a:r>
+                    </a:p>
+                  </a:txBody>
+                  <a:tcPr/>
+                </a:tc>
+                <a:tc>
+                  <a:txBody>
+                    <a:bodyPr/>
+                    <a:lstStyle/>
+                    <a:p>
+                      <a:r>
+                        <a:rPr sz="1400"/>
+                        <a:t>ООО «Ромашка»</a:t>
+                      </a:r>
+                    </a:p>
+                  </a:txBody>
+                  <a:tcPr/>
+                </a:tc>
+                <a:tc>
+                  <a:txBody>
+                    <a:bodyPr/>
+                    <a:lstStyle/>
+                    <a:p>
+                      <a:r>
+                        <a:rPr sz="1400"/>
+                        <a:t>12 480,00</a:t>
+                      </a:r>
+                    </a:p>
+                  </a:txBody>
+                  <a:tcPr/>
+                </a:tc>
+                <a:tc>
+                  <a:txBody>
+                    <a:bodyPr/>
+                    <a:lstStyle/>
+                    <a:p>
+                      <a:r>
+                        <a:rPr sz="1400"/>
+                        <a:t>Действует</a:t>
+                      </a:r>
+                    </a:p>
+                  </a:txBody>
+                  <a:tcPr/>
+                </a:tc>
+              </a:tr>
+              <a:tr h="576000">
+                <a:tc>
+                  <a:txBody>
+                    <a:bodyPr/>
+                    <a:lstStyle/>
+                    <a:p>
+                      <a:r>
+                        <a:rPr sz="1400"/>
+                        <a:t>№ 18/2024</a:t>
+                      </a:r>
+                    </a:p>
+                  </a:txBody>
+                  <a:tcPr/>
+                </a:tc>
+                <a:tc>
+                  <a:txBody>
+                    <a:bodyPr/>
+                    <a:lstStyle/>
+                    <a:p>
+                      <a:r>
+                        <a:rPr sz="1400"/>
+                        <a:t>ИП Иванов И. И.</a:t>
+                      </a:r>
+                    </a:p>
+                  </a:txBody>
+                  <a:tcPr/>
+                </a:tc>
+                <a:tc>
+                  <a:txBody>
+                    <a:bodyPr/>
+                    <a:lstStyle/>
+                    <a:p>
+                      <a:r>
+                        <a:rPr sz="1400"/>
+                        <a:t>15 630,00</a:t>
+                      </a:r>
+                    </a:p>
+                  </a:txBody>
+                  <a:tcPr/>
+                </a:tc>
+                <a:tc>
+                  <a:txBody>
+                    <a:bodyPr/>
+                    <a:lstStyle/>
+                    <a:p>
+                      <a:r>
+                        <a:rPr sz="1400"/>
+                        <a:t>На согласовании</a:t>
+                      </a:r>
+                    </a:p>
+                  </a:txBody>
+                  <a:tcPr/>
+                </a:tc>
+              </a:tr>
+              <a:tr h="576000">
+                <a:tc>
+                  <a:txBody>
+                    <a:bodyPr/>
+                    <a:lstStyle/>
+                    <a:p>
+                      <a:r>
+                        <a:rPr sz="1400"/>
+                        <a:t>№ 19/2024</a:t>
+                      </a:r>
+                    </a:p>
+                  </a:txBody>
+                  <a:tcPr/>
+                </a:tc>
+                <a:tc>
+                  <a:txBody>
+                    <a:bodyPr/>
+                    <a:lstStyle/>
+                    <a:p>
+                      <a:r>
+                        <a:rPr sz="1400"/>
+                        <a:t>ООО «Василёк»</a:t>
+                      </a:r>
+                    </a:p>
+                  </a:txBody>
+                  <a:tcPr/>
+                </a:tc>
+                <a:tc>
+                  <a:txBody>
+                    <a:bodyPr/>
+                    <a:lstStyle/>
+                    <a:p>
+                      <a:r>
+                        <a:rPr sz="1400"/>
+                        <a:t>18 780,00</a:t>
+                      </a:r>
+                    </a:p>
+                  </a:txBody>
+                  <a:tcPr/>
+                </a:tc>
+                <a:tc>
+                  <a:txBody>
+                    <a:bodyPr/>
+                    <a:lstStyle/>
+                    <a:p>
+                      <a:r>
+                        <a:rPr sz="1400"/>
+                        <a:t>Завершён</a:t>
+                      </a:r>
+                    </a:p>
+                  </a:txBody>
+                  <a:tcPr/>
+                </a:tc>
+              </a:tr>
+              <a:tr h="576000">
+                <a:tc>
+                  <a:txBody>
+                    <a:bodyPr/>
+                    <a:lstStyle/>
+                    <a:p>
+                      <a:r>
+                        <a:rPr sz="1400"/>
+                        <a:t>№ 20/2024</a:t>
+                      </a:r>
+                    </a:p>
+                  </a:txBody>
+                  <a:tcPr/>
+                </a:tc>
+                <a:tc>
+                  <a:txBody>
+                    <a:bodyPr/>
+                    <a:lstStyle/>
+                    <a:p>
+                      <a:r>
+                        <a:rPr sz="1400"/>
+                        <a:t>ЗАО «Тестовый Мост»</a:t>
+                      </a:r>
+                    </a:p>
+                  </a:txBody>
+                  <a:tcPr/>
+                </a:tc>
+                <a:tc>
+                  <a:txBody>
+                    <a:bodyPr/>
+                    <a:lstStyle/>
+                    <a:p>
+                      <a:r>
+                        <a:rPr sz="1400"/>
+                        <a:t>21 930,00</a:t>
+                      </a:r>
+                    </a:p>
+                  </a:txBody>
+                  <a:tcPr/>
+                </a:tc>
+                <a:tc>
+                  <a:txBody>
+                    <a:bodyPr/>
+                    <a:lstStyle/>
+                    <a:p>
+                      <a:r>
+                        <a:rPr sz="1400"/>
+                        <a:t>Продлён</a:t>
+                      </a:r>
+                    </a:p>
+                  </a:txBody>
+                  <a:tcPr/>
+                </a:tc>
+              </a:tr>
+            </a:tbl>
+          </a:graphicData>
+        </a:graphic>
+      </p:graphicFrame>
     </p:spTree>
   </p:cSld>
   <p:clrMapOvr>
@@ -3327,44 +3584,367 @@
           <a:lstStyle/>
           <a:p>
             <a:r>
-              <a:t>Раздел 11</a:t>
-            </a:r>
-          </a:p>
-        </p:txBody>
-      </p:sp>
-      <p:sp>
-        <p:nvSpPr>
-          <p:cNvPr id="3" name="Content Placeholder 2"/>
-          <p:cNvSpPr>
-            <a:spLocks noGrp="1"/>
-          </p:cNvSpPr>
-          <p:nvPr>
-            <p:ph idx="1"/>
-          </p:nvPr>
-        </p:nvSpPr>
-        <p:spPr/>
-        <p:txBody>
-          <a:bodyPr/>
-          <a:lstStyle/>
-          <a:p>
-            <a:r>
-              <a:t>Ключевой показатель 11</a:t>
-            </a:r>
-          </a:p>
-          <a:p>
-            <a:pPr lvl="1">
-              <a:defRPr sz="1800"/>
-            </a:pPr>
-            <a:r>
-              <a:t>Пояснение 11.1</a:t>
-            </a:r>
-          </a:p>
-          <a:p>
-            <a:pPr lvl="1">
-              <a:defRPr sz="1800"/>
-            </a:pPr>
-            <a:r>
-              <a:t>Пояснение 11.2</a:t>
+              <a:t>Динамика подписаний (шт.)</a:t>
+            </a:r>
+          </a:p>
+        </p:txBody>
+      </p:sp>
+      <p:sp>
+        <p:nvSpPr>
+          <p:cNvPr id="3" name="Rectangle 2"/>
+          <p:cNvSpPr/>
+          <p:nvPr/>
+        </p:nvSpPr>
+        <p:spPr>
+          <a:xfrm>
+            <a:off x="1080000" y="3168000"/>
+            <a:ext cx="792000" cy="1512000"/>
+          </a:xfrm>
+          <a:prstGeom prst="rect">
+            <a:avLst/>
+          </a:prstGeom>
+          <a:solidFill>
+            <a:srgbClr val="0F6A88"/>
+          </a:solidFill>
+          <a:ln>
+            <a:noFill/>
+          </a:ln>
+        </p:spPr>
+        <p:style>
+          <a:lnRef idx="1">
+            <a:schemeClr val="accent1"/>
+          </a:lnRef>
+          <a:fillRef idx="3">
+            <a:schemeClr val="accent1"/>
+          </a:fillRef>
+          <a:effectRef idx="2">
+            <a:schemeClr val="accent1"/>
+          </a:effectRef>
+          <a:fontRef idx="minor">
+            <a:schemeClr val="lt1"/>
+          </a:fontRef>
+        </p:style>
+        <p:txBody>
+          <a:bodyPr rtlCol="0" anchor="ctr"/>
+          <a:lstStyle/>
+          <a:p>
+            <a:pPr algn="ctr"/>
+          </a:p>
+        </p:txBody>
+      </p:sp>
+      <p:sp>
+        <p:nvSpPr>
+          <p:cNvPr id="4" name="TextBox 3"/>
+          <p:cNvSpPr txBox="1"/>
+          <p:nvPr/>
+        </p:nvSpPr>
+        <p:spPr>
+          <a:xfrm>
+            <a:off x="1080000" y="4680000"/>
+            <a:ext cx="792000" cy="360000"/>
+          </a:xfrm>
+          <a:prstGeom prst="rect">
+            <a:avLst/>
+          </a:prstGeom>
+          <a:noFill/>
+        </p:spPr>
+        <p:txBody>
+          <a:bodyPr wrap="none">
+            <a:spAutoFit/>
+          </a:bodyPr>
+          <a:lstStyle/>
+          <a:p>
+            <a:r>
+              <a:rPr sz="1100"/>
+              <a:t>Янв — 42</a:t>
+            </a:r>
+          </a:p>
+        </p:txBody>
+      </p:sp>
+      <p:sp>
+        <p:nvSpPr>
+          <p:cNvPr id="5" name="Rectangle 4"/>
+          <p:cNvSpPr/>
+          <p:nvPr/>
+        </p:nvSpPr>
+        <p:spPr>
+          <a:xfrm>
+            <a:off x="2232000" y="2232000"/>
+            <a:ext cx="792000" cy="2448000"/>
+          </a:xfrm>
+          <a:prstGeom prst="rect">
+            <a:avLst/>
+          </a:prstGeom>
+          <a:solidFill>
+            <a:srgbClr val="0F6A88"/>
+          </a:solidFill>
+          <a:ln>
+            <a:noFill/>
+          </a:ln>
+        </p:spPr>
+        <p:style>
+          <a:lnRef idx="1">
+            <a:schemeClr val="accent1"/>
+          </a:lnRef>
+          <a:fillRef idx="3">
+            <a:schemeClr val="accent1"/>
+          </a:fillRef>
+          <a:effectRef idx="2">
+            <a:schemeClr val="accent1"/>
+          </a:effectRef>
+          <a:fontRef idx="minor">
+            <a:schemeClr val="lt1"/>
+          </a:fontRef>
+        </p:style>
+        <p:txBody>
+          <a:bodyPr rtlCol="0" anchor="ctr"/>
+          <a:lstStyle/>
+          <a:p>
+            <a:pPr algn="ctr"/>
+          </a:p>
+        </p:txBody>
+      </p:sp>
+      <p:sp>
+        <p:nvSpPr>
+          <p:cNvPr id="6" name="TextBox 5"/>
+          <p:cNvSpPr txBox="1"/>
+          <p:nvPr/>
+        </p:nvSpPr>
+        <p:spPr>
+          <a:xfrm>
+            <a:off x="2232000" y="4680000"/>
+            <a:ext cx="792000" cy="360000"/>
+          </a:xfrm>
+          <a:prstGeom prst="rect">
+            <a:avLst/>
+          </a:prstGeom>
+          <a:noFill/>
+        </p:spPr>
+        <p:txBody>
+          <a:bodyPr wrap="none">
+            <a:spAutoFit/>
+          </a:bodyPr>
+          <a:lstStyle/>
+          <a:p>
+            <a:r>
+              <a:rPr sz="1100"/>
+              <a:t>Фев — 68</a:t>
+            </a:r>
+          </a:p>
+        </p:txBody>
+      </p:sp>
+      <p:sp>
+        <p:nvSpPr>
+          <p:cNvPr id="7" name="Rectangle 6"/>
+          <p:cNvSpPr/>
+          <p:nvPr/>
+        </p:nvSpPr>
+        <p:spPr>
+          <a:xfrm>
+            <a:off x="3384000" y="2700000"/>
+            <a:ext cx="792000" cy="1980000"/>
+          </a:xfrm>
+          <a:prstGeom prst="rect">
+            <a:avLst/>
+          </a:prstGeom>
+          <a:solidFill>
+            <a:srgbClr val="0F6A88"/>
+          </a:solidFill>
+          <a:ln>
+            <a:noFill/>
+          </a:ln>
+        </p:spPr>
+        <p:style>
+          <a:lnRef idx="1">
+            <a:schemeClr val="accent1"/>
+          </a:lnRef>
+          <a:fillRef idx="3">
+            <a:schemeClr val="accent1"/>
+          </a:fillRef>
+          <a:effectRef idx="2">
+            <a:schemeClr val="accent1"/>
+          </a:effectRef>
+          <a:fontRef idx="minor">
+            <a:schemeClr val="lt1"/>
+          </a:fontRef>
+        </p:style>
+        <p:txBody>
+          <a:bodyPr rtlCol="0" anchor="ctr"/>
+          <a:lstStyle/>
+          <a:p>
+            <a:pPr algn="ctr"/>
+          </a:p>
+        </p:txBody>
+      </p:sp>
+      <p:sp>
+        <p:nvSpPr>
+          <p:cNvPr id="8" name="TextBox 7"/>
+          <p:cNvSpPr txBox="1"/>
+          <p:nvPr/>
+        </p:nvSpPr>
+        <p:spPr>
+          <a:xfrm>
+            <a:off x="3384000" y="4680000"/>
+            <a:ext cx="792000" cy="360000"/>
+          </a:xfrm>
+          <a:prstGeom prst="rect">
+            <a:avLst/>
+          </a:prstGeom>
+          <a:noFill/>
+        </p:spPr>
+        <p:txBody>
+          <a:bodyPr wrap="none">
+            <a:spAutoFit/>
+          </a:bodyPr>
+          <a:lstStyle/>
+          <a:p>
+            <a:r>
+              <a:rPr sz="1100"/>
+              <a:t>Мар — 55</a:t>
+            </a:r>
+          </a:p>
+        </p:txBody>
+      </p:sp>
+      <p:sp>
+        <p:nvSpPr>
+          <p:cNvPr id="9" name="Rectangle 8"/>
+          <p:cNvSpPr/>
+          <p:nvPr/>
+        </p:nvSpPr>
+        <p:spPr>
+          <a:xfrm>
+            <a:off x="4536000" y="1404000"/>
+            <a:ext cx="792000" cy="3276000"/>
+          </a:xfrm>
+          <a:prstGeom prst="rect">
+            <a:avLst/>
+          </a:prstGeom>
+          <a:solidFill>
+            <a:srgbClr val="0F6A88"/>
+          </a:solidFill>
+          <a:ln>
+            <a:noFill/>
+          </a:ln>
+        </p:spPr>
+        <p:style>
+          <a:lnRef idx="1">
+            <a:schemeClr val="accent1"/>
+          </a:lnRef>
+          <a:fillRef idx="3">
+            <a:schemeClr val="accent1"/>
+          </a:fillRef>
+          <a:effectRef idx="2">
+            <a:schemeClr val="accent1"/>
+          </a:effectRef>
+          <a:fontRef idx="minor">
+            <a:schemeClr val="lt1"/>
+          </a:fontRef>
+        </p:style>
+        <p:txBody>
+          <a:bodyPr rtlCol="0" anchor="ctr"/>
+          <a:lstStyle/>
+          <a:p>
+            <a:pPr algn="ctr"/>
+          </a:p>
+        </p:txBody>
+      </p:sp>
+      <p:sp>
+        <p:nvSpPr>
+          <p:cNvPr id="10" name="TextBox 9"/>
+          <p:cNvSpPr txBox="1"/>
+          <p:nvPr/>
+        </p:nvSpPr>
+        <p:spPr>
+          <a:xfrm>
+            <a:off x="4536000" y="4680000"/>
+            <a:ext cx="792000" cy="360000"/>
+          </a:xfrm>
+          <a:prstGeom prst="rect">
+            <a:avLst/>
+          </a:prstGeom>
+          <a:noFill/>
+        </p:spPr>
+        <p:txBody>
+          <a:bodyPr wrap="none">
+            <a:spAutoFit/>
+          </a:bodyPr>
+          <a:lstStyle/>
+          <a:p>
+            <a:r>
+              <a:rPr sz="1100"/>
+              <a:t>Апр — 91</a:t>
+            </a:r>
+          </a:p>
+        </p:txBody>
+      </p:sp>
+      <p:sp>
+        <p:nvSpPr>
+          <p:cNvPr id="11" name="Rectangle 10"/>
+          <p:cNvSpPr/>
+          <p:nvPr/>
+        </p:nvSpPr>
+        <p:spPr>
+          <a:xfrm>
+            <a:off x="5688000" y="2016000"/>
+            <a:ext cx="792000" cy="2664000"/>
+          </a:xfrm>
+          <a:prstGeom prst="rect">
+            <a:avLst/>
+          </a:prstGeom>
+          <a:solidFill>
+            <a:srgbClr val="0F6A88"/>
+          </a:solidFill>
+          <a:ln>
+            <a:noFill/>
+          </a:ln>
+        </p:spPr>
+        <p:style>
+          <a:lnRef idx="1">
+            <a:schemeClr val="accent1"/>
+          </a:lnRef>
+          <a:fillRef idx="3">
+            <a:schemeClr val="accent1"/>
+          </a:fillRef>
+          <a:effectRef idx="2">
+            <a:schemeClr val="accent1"/>
+          </a:effectRef>
+          <a:fontRef idx="minor">
+            <a:schemeClr val="lt1"/>
+          </a:fontRef>
+        </p:style>
+        <p:txBody>
+          <a:bodyPr rtlCol="0" anchor="ctr"/>
+          <a:lstStyle/>
+          <a:p>
+            <a:pPr algn="ctr"/>
+          </a:p>
+        </p:txBody>
+      </p:sp>
+      <p:sp>
+        <p:nvSpPr>
+          <p:cNvPr id="12" name="TextBox 11"/>
+          <p:cNvSpPr txBox="1"/>
+          <p:nvPr/>
+        </p:nvSpPr>
+        <p:spPr>
+          <a:xfrm>
+            <a:off x="5688000" y="4680000"/>
+            <a:ext cx="792000" cy="360000"/>
+          </a:xfrm>
+          <a:prstGeom prst="rect">
+            <a:avLst/>
+          </a:prstGeom>
+          <a:noFill/>
+        </p:spPr>
+        <p:txBody>
+          <a:bodyPr wrap="none">
+            <a:spAutoFit/>
+          </a:bodyPr>
+          <a:lstStyle/>
+          <a:p>
+            <a:r>
+              <a:rPr sz="1100"/>
+              <a:t>Май — 74</a:t>
             </a:r>
           </a:p>
         </p:txBody>
@@ -3403,7 +3983,7 @@
           <a:lstStyle/>
           <a:p>
             <a:r>
-              <a:t>Раздел 1</a:t>
+              <a:t>Итоги квартала</a:t>
             </a:r>
           </a:p>
         </p:txBody>
@@ -3424,23 +4004,19 @@
           <a:lstStyle/>
           <a:p>
             <a:r>
-              <a:t>Ключевой показатель 1</a:t>
-            </a:r>
-          </a:p>
-          <a:p>
-            <a:pPr lvl="1">
-              <a:defRPr sz="1800"/>
-            </a:pPr>
-            <a:r>
-              <a:t>Пояснение 1.1</a:t>
-            </a:r>
-          </a:p>
-          <a:p>
-            <a:pPr lvl="1">
-              <a:defRPr sz="1800"/>
-            </a:pPr>
-            <a:r>
-              <a:t>Пояснение 1.2</a:t>
+              <a:t>Выручка выросла на 12% к предыдущему кварталу</a:t>
+            </a:r>
+          </a:p>
+          <a:p>
+            <a:pPr lvl="1"/>
+            <a:r>
+              <a:t>Подписано 8 новых договоров</a:t>
+            </a:r>
+          </a:p>
+          <a:p>
+            <a:pPr lvl="1"/>
+            <a:r>
+              <a:t>Средний срок согласования — 6 рабочих дней</a:t>
             </a:r>
           </a:p>
         </p:txBody>
@@ -3479,7 +4055,7 @@
           <a:lstStyle/>
           <a:p>
             <a:r>
-              <a:t>Раздел 2</a:t>
+              <a:t>Структура портфеля</a:t>
             </a:r>
           </a:p>
         </p:txBody>
@@ -3500,23 +4076,19 @@
           <a:lstStyle/>
           <a:p>
             <a:r>
-              <a:t>Ключевой показатель 2</a:t>
-            </a:r>
-          </a:p>
-          <a:p>
-            <a:pPr lvl="1">
-              <a:defRPr sz="1800"/>
-            </a:pPr>
-            <a:r>
-              <a:t>Пояснение 2.1</a:t>
-            </a:r>
-          </a:p>
-          <a:p>
-            <a:pPr lvl="1">
-              <a:defRPr sz="1800"/>
-            </a:pPr>
-            <a:r>
-              <a:t>Пояснение 2.2</a:t>
+              <a:t>Услуги — 54%</a:t>
+            </a:r>
+          </a:p>
+          <a:p>
+            <a:pPr lvl="1"/>
+            <a:r>
+              <a:t>Поставка — 31%</a:t>
+            </a:r>
+          </a:p>
+          <a:p>
+            <a:pPr lvl="1"/>
+            <a:r>
+              <a:t>Аренда — 15%</a:t>
             </a:r>
           </a:p>
         </p:txBody>
@@ -3555,7 +4127,7 @@
           <a:lstStyle/>
           <a:p>
             <a:r>
-              <a:t>Раздел 3</a:t>
+              <a:t>Ключевые контрагенты</a:t>
             </a:r>
           </a:p>
         </p:txBody>
@@ -3576,23 +4148,19 @@
           <a:lstStyle/>
           <a:p>
             <a:r>
-              <a:t>Ключевой показатель 3</a:t>
-            </a:r>
-          </a:p>
-          <a:p>
-            <a:pPr lvl="1">
-              <a:defRPr sz="1800"/>
-            </a:pPr>
-            <a:r>
-              <a:t>Пояснение 3.1</a:t>
-            </a:r>
-          </a:p>
-          <a:p>
-            <a:pPr lvl="1">
-              <a:defRPr sz="1800"/>
-            </a:pPr>
-            <a:r>
-              <a:t>Пояснение 3.2</a:t>
+              <a:t>ООО «Василёк»</a:t>
+            </a:r>
+          </a:p>
+          <a:p>
+            <a:pPr lvl="1"/>
+            <a:r>
+              <a:t>ЗАО «Тестовый Мост»</a:t>
+            </a:r>
+          </a:p>
+          <a:p>
+            <a:pPr lvl="1"/>
+            <a:r>
+              <a:t>ООО «ТехноСфера-Плюс»</a:t>
             </a:r>
           </a:p>
         </p:txBody>
@@ -3631,7 +4199,7 @@
           <a:lstStyle/>
           <a:p>
             <a:r>
-              <a:t>Раздел 4</a:t>
+              <a:t>Просроченная задолженность</a:t>
             </a:r>
           </a:p>
         </p:txBody>
@@ -3652,23 +4220,19 @@
           <a:lstStyle/>
           <a:p>
             <a:r>
-              <a:t>Ключевой показатель 4</a:t>
-            </a:r>
-          </a:p>
-          <a:p>
-            <a:pPr lvl="1">
-              <a:defRPr sz="1800"/>
-            </a:pPr>
-            <a:r>
-              <a:t>Пояснение 4.1</a:t>
-            </a:r>
-          </a:p>
-          <a:p>
-            <a:pPr lvl="1">
-              <a:defRPr sz="1800"/>
-            </a:pPr>
-            <a:r>
-              <a:t>Пояснение 4.2</a:t>
+              <a:t>Всего 4 договора</a:t>
+            </a:r>
+          </a:p>
+          <a:p>
+            <a:pPr lvl="1"/>
+            <a:r>
+              <a:t>Средний срок просрочки — 11 дней</a:t>
+            </a:r>
+          </a:p>
+          <a:p>
+            <a:pPr lvl="1"/>
+            <a:r>
+              <a:t>Претензионная работа начата по 3 из 4</a:t>
             </a:r>
           </a:p>
         </p:txBody>
@@ -3707,7 +4271,7 @@
           <a:lstStyle/>
           <a:p>
             <a:r>
-              <a:t>Раздел 5</a:t>
+              <a:t>Процесс согласования</a:t>
             </a:r>
           </a:p>
         </p:txBody>
@@ -3728,23 +4292,25 @@
           <a:lstStyle/>
           <a:p>
             <a:r>
-              <a:t>Ключевой показатель 5</a:t>
-            </a:r>
-          </a:p>
-          <a:p>
-            <a:pPr lvl="1">
-              <a:defRPr sz="1800"/>
-            </a:pPr>
-            <a:r>
-              <a:t>Пояснение 5.1</a:t>
-            </a:r>
-          </a:p>
-          <a:p>
-            <a:pPr lvl="1">
-              <a:defRPr sz="1800"/>
-            </a:pPr>
-            <a:r>
-              <a:t>Пояснение 5.2</a:t>
+              <a:t>Заявка</a:t>
+            </a:r>
+          </a:p>
+          <a:p>
+            <a:pPr lvl="1"/>
+            <a:r>
+              <a:t>Проверка контрагента</a:t>
+            </a:r>
+          </a:p>
+          <a:p>
+            <a:pPr lvl="1"/>
+            <a:r>
+              <a:t>Юридическая экспертиза</a:t>
+            </a:r>
+          </a:p>
+          <a:p>
+            <a:pPr lvl="1"/>
+            <a:r>
+              <a:t>Подписание</a:t>
             </a:r>
           </a:p>
         </p:txBody>
@@ -3783,7 +4349,7 @@
           <a:lstStyle/>
           <a:p>
             <a:r>
-              <a:t>Раздел 6</a:t>
+              <a:t>Риски</a:t>
             </a:r>
           </a:p>
         </p:txBody>
@@ -3804,23 +4370,19 @@
           <a:lstStyle/>
           <a:p>
             <a:r>
-              <a:t>Ключевой показатель 6</a:t>
-            </a:r>
-          </a:p>
-          <a:p>
-            <a:pPr lvl="1">
-              <a:defRPr sz="1800"/>
-            </a:pPr>
-            <a:r>
-              <a:t>Пояснение 6.1</a:t>
-            </a:r>
-          </a:p>
-          <a:p>
-            <a:pPr lvl="1">
-              <a:defRPr sz="1800"/>
-            </a:pPr>
-            <a:r>
-              <a:t>Пояснение 6.2</a:t>
+              <a:t>Зависимость от одного поставщика</a:t>
+            </a:r>
+          </a:p>
+          <a:p>
+            <a:pPr lvl="1"/>
+            <a:r>
+              <a:t>Валютные колебания</a:t>
+            </a:r>
+          </a:p>
+          <a:p>
+            <a:pPr lvl="1"/>
+            <a:r>
+              <a:t>Сроки поставки оборудования</a:t>
             </a:r>
           </a:p>
         </p:txBody>
@@ -3859,7 +4421,7 @@
           <a:lstStyle/>
           <a:p>
             <a:r>
-              <a:t>Раздел 7</a:t>
+              <a:t>План на следующий квартал</a:t>
             </a:r>
           </a:p>
         </p:txBody>
@@ -3880,23 +4442,19 @@
           <a:lstStyle/>
           <a:p>
             <a:r>
-              <a:t>Ключевой показатель 7</a:t>
-            </a:r>
-          </a:p>
-          <a:p>
-            <a:pPr lvl="1">
-              <a:defRPr sz="1800"/>
-            </a:pPr>
-            <a:r>
-              <a:t>Пояснение 7.1</a:t>
-            </a:r>
-          </a:p>
-          <a:p>
-            <a:pPr lvl="1">
-              <a:defRPr sz="1800"/>
-            </a:pPr>
-            <a:r>
-              <a:t>Пояснение 7.2</a:t>
+              <a:t>Перевести 60% договоров в электронный вид</a:t>
+            </a:r>
+          </a:p>
+          <a:p>
+            <a:pPr lvl="1"/>
+            <a:r>
+              <a:t>Сократить срок согласования до 4 дней</a:t>
+            </a:r>
+          </a:p>
+          <a:p>
+            <a:pPr lvl="1"/>
+            <a:r>
+              <a:t>Запустить реестр в общем доступе</a:t>
             </a:r>
           </a:p>
         </p:txBody>
@@ -3935,7 +4493,7 @@
           <a:lstStyle/>
           <a:p>
             <a:r>
-              <a:t>Раздел 8</a:t>
+              <a:t>Бюджет проекта</a:t>
             </a:r>
           </a:p>
         </p:txBody>
@@ -3956,23 +4514,19 @@
           <a:lstStyle/>
           <a:p>
             <a:r>
-              <a:t>Ключевой показатель 8</a:t>
-            </a:r>
-          </a:p>
-          <a:p>
-            <a:pPr lvl="1">
-              <a:defRPr sz="1800"/>
-            </a:pPr>
-            <a:r>
-              <a:t>Пояснение 8.1</a:t>
-            </a:r>
-          </a:p>
-          <a:p>
-            <a:pPr lvl="1">
-              <a:defRPr sz="1800"/>
-            </a:pPr>
-            <a:r>
-              <a:t>Пояснение 8.2</a:t>
+              <a:t>Расходы на лицензии — 18 400 BYN</a:t>
+            </a:r>
+          </a:p>
+          <a:p>
+            <a:pPr lvl="1"/>
+            <a:r>
+              <a:t>Обучение — 6 200 BYN</a:t>
+            </a:r>
+          </a:p>
+          <a:p>
+            <a:pPr lvl="1"/>
+            <a:r>
+              <a:t>Резерв — 5 000 BYN</a:t>
             </a:r>
           </a:p>
         </p:txBody>

</xml_diff>

<commit_message>
test(e2e): make the fixtures carry the exact text the specs assert
The previous commit captured an intermediate set whose wording no longer
matched the literal strings the specs look for, which is what the five
failing matrix tests were actually reporting. The documents now contain
those strings naturally, and the fixture verifier guards all eight of them,
so rephrasing a document fails there with a clear message instead of
surfacing as a mysterious Playwright timeout.

Markers were confirmed independently of the generator by extracting the
text back out of each document.

Co-Authored-By: Claude Fable 5 <noreply@anthropic.com>
</commit_message>
<xml_diff>
--- a/e2e/fixtures/files/deck-16x9.pptx
+++ b/e2e/fixtures/files/deck-16x9.pptx
@@ -3983,7 +3983,7 @@
           <a:lstStyle/>
           <a:p>
             <a:r>
-              <a:t>Итоги квартала</a:t>
+              <a:t>Итоги полугодия</a:t>
             </a:r>
           </a:p>
         </p:txBody>
@@ -4003,6 +4003,12 @@
           <a:bodyPr/>
           <a:lstStyle/>
           <a:p>
+            <a:r>
+              <a:t>Раздел 1. Ключевые показатели за период</a:t>
+            </a:r>
+          </a:p>
+          <a:p>
+            <a:pPr lvl="1"/>
             <a:r>
               <a:t>Выручка выросла на 12% к предыдущему кварталу</a:t>
             </a:r>

</xml_diff>